<commit_message>
AI 100 card: Primary Commodity Fund, winner box removed
Co-Authored-By: Claude Fable 5.1 <noreply@anthropic.com>
</commit_message>
<xml_diff>
--- a/awards/H2O-AI100-Winner-2026-Peter-Cotton.pptx
+++ b/awards/H2O-AI100-Winner-2026-Peter-Cotton.pptx
@@ -1031,57 +1031,6 @@
       </p:pic>
       <p:sp>
         <p:nvSpPr>
-          <p:cNvPr id="13" name="Google Shape;13;p2"/>
-          <p:cNvSpPr/>
-          <p:nvPr/>
-        </p:nvSpPr>
-        <p:spPr>
-          <a:xfrm rot="10800000">
-            <a:off x="3216225" y="-31175"/>
-            <a:ext cx="3854700" cy="1405500"/>
-          </a:xfrm>
-          <a:prstGeom prst="round2SameRect">
-            <a:avLst>
-              <a:gd fmla="val 9098" name="adj1"/>
-              <a:gd fmla="val 0" name="adj2"/>
-            </a:avLst>
-          </a:prstGeom>
-          <a:solidFill>
-            <a:srgbClr val="FFDD00"/>
-          </a:solidFill>
-          <a:ln>
-            <a:noFill/>
-          </a:ln>
-        </p:spPr>
-        <p:txBody>
-          <a:bodyPr anchorCtr="0" anchor="ctr" bIns="91425" lIns="91425" spcFirstLastPara="1" rIns="91425" wrap="square" tIns="91425">
-            <a:noAutofit/>
-          </a:bodyPr>
-          <a:lstStyle/>
-          <a:p>
-            <a:pPr indent="0" lvl="0" marL="0" rtl="0" algn="ctr">
-              <a:spcBef>
-                <a:spcPts val="0"/>
-              </a:spcBef>
-              <a:spcAft>
-                <a:spcPts val="0"/>
-              </a:spcAft>
-              <a:buNone/>
-            </a:pPr>
-            <a:r>
-              <a:t/>
-            </a:r>
-            <a:endParaRPr>
-              <a:latin typeface="Inter"/>
-              <a:ea typeface="Inter"/>
-              <a:cs typeface="Inter"/>
-              <a:sym typeface="Inter"/>
-            </a:endParaRPr>
-          </a:p>
-        </p:txBody>
-      </p:sp>
-      <p:sp>
-        <p:nvSpPr>
           <p:cNvPr id="14" name="Google Shape;14;p2"/>
           <p:cNvSpPr txBox="1"/>
           <p:nvPr>
@@ -1427,58 +1376,6 @@
             </a:lvl9pPr>
           </a:lstStyle>
           <a:p/>
-        </p:txBody>
-      </p:sp>
-      <p:sp>
-        <p:nvSpPr>
-          <p:cNvPr id="16" name="Google Shape;16;p2"/>
-          <p:cNvSpPr txBox="1"/>
-          <p:nvPr/>
-        </p:nvSpPr>
-        <p:spPr>
-          <a:xfrm>
-            <a:off x="3474727" y="598486"/>
-            <a:ext cx="3337500" cy="646500"/>
-          </a:xfrm>
-          <a:prstGeom prst="rect">
-            <a:avLst/>
-          </a:prstGeom>
-          <a:noFill/>
-          <a:ln>
-            <a:noFill/>
-          </a:ln>
-        </p:spPr>
-        <p:txBody>
-          <a:bodyPr anchorCtr="0" anchor="b" bIns="91425" lIns="91425" spcFirstLastPara="1" rIns="91425" wrap="square" tIns="91425">
-            <a:spAutoFit/>
-          </a:bodyPr>
-          <a:lstStyle/>
-          <a:p>
-            <a:pPr indent="0" lvl="0" marL="0" rtl="0" algn="ctr">
-              <a:spcBef>
-                <a:spcPts val="0"/>
-              </a:spcBef>
-              <a:spcAft>
-                <a:spcPts val="0"/>
-              </a:spcAft>
-              <a:buNone/>
-            </a:pPr>
-            <a:r>
-              <a:rPr lang="en" sz="3000">
-                <a:latin typeface="Montserrat SemiBold"/>
-                <a:ea typeface="Montserrat SemiBold"/>
-                <a:cs typeface="Montserrat SemiBold"/>
-                <a:sym typeface="Montserrat SemiBold"/>
-              </a:rPr>
-              <a:t>W I N N E R</a:t>
-            </a:r>
-            <a:endParaRPr sz="3000">
-              <a:latin typeface="Montserrat SemiBold"/>
-              <a:ea typeface="Montserrat SemiBold"/>
-              <a:cs typeface="Montserrat SemiBold"/>
-              <a:sym typeface="Montserrat SemiBold"/>
-            </a:endParaRPr>
-          </a:p>
         </p:txBody>
       </p:sp>
       <p:sp>
@@ -2449,57 +2346,6 @@
       </p:pic>
       <p:sp>
         <p:nvSpPr>
-          <p:cNvPr id="28" name="Google Shape;28;p3"/>
-          <p:cNvSpPr/>
-          <p:nvPr/>
-        </p:nvSpPr>
-        <p:spPr>
-          <a:xfrm>
-            <a:off x="3769725" y="9304275"/>
-            <a:ext cx="2760300" cy="1018800"/>
-          </a:xfrm>
-          <a:prstGeom prst="round2SameRect">
-            <a:avLst>
-              <a:gd fmla="val 9098" name="adj1"/>
-              <a:gd fmla="val 0" name="adj2"/>
-            </a:avLst>
-          </a:prstGeom>
-          <a:solidFill>
-            <a:srgbClr val="FFDD00"/>
-          </a:solidFill>
-          <a:ln>
-            <a:noFill/>
-          </a:ln>
-        </p:spPr>
-        <p:txBody>
-          <a:bodyPr anchorCtr="0" anchor="ctr" bIns="79150" lIns="79150" spcFirstLastPara="1" rIns="79150" wrap="square" tIns="79150">
-            <a:noAutofit/>
-          </a:bodyPr>
-          <a:lstStyle/>
-          <a:p>
-            <a:pPr indent="0" lvl="0" marL="0" rtl="0" algn="ctr">
-              <a:spcBef>
-                <a:spcPts val="0"/>
-              </a:spcBef>
-              <a:spcAft>
-                <a:spcPts val="0"/>
-              </a:spcAft>
-              <a:buNone/>
-            </a:pPr>
-            <a:r>
-              <a:t/>
-            </a:r>
-            <a:endParaRPr sz="1212">
-              <a:latin typeface="Inter"/>
-              <a:ea typeface="Inter"/>
-              <a:cs typeface="Inter"/>
-              <a:sym typeface="Inter"/>
-            </a:endParaRPr>
-          </a:p>
-        </p:txBody>
-      </p:sp>
-      <p:sp>
-        <p:nvSpPr>
           <p:cNvPr id="29" name="Google Shape;29;p3"/>
           <p:cNvSpPr txBox="1"/>
           <p:nvPr>
@@ -2845,58 +2691,6 @@
             </a:lvl9pPr>
           </a:lstStyle>
           <a:p/>
-        </p:txBody>
-      </p:sp>
-      <p:sp>
-        <p:nvSpPr>
-          <p:cNvPr id="31" name="Google Shape;31;p3"/>
-          <p:cNvSpPr txBox="1"/>
-          <p:nvPr/>
-        </p:nvSpPr>
-        <p:spPr>
-          <a:xfrm>
-            <a:off x="3474727" y="9294961"/>
-            <a:ext cx="3337500" cy="585000"/>
-          </a:xfrm>
-          <a:prstGeom prst="rect">
-            <a:avLst/>
-          </a:prstGeom>
-          <a:noFill/>
-          <a:ln>
-            <a:noFill/>
-          </a:ln>
-        </p:spPr>
-        <p:txBody>
-          <a:bodyPr anchorCtr="0" anchor="b" bIns="91425" lIns="91425" spcFirstLastPara="1" rIns="91425" wrap="square" tIns="91425">
-            <a:spAutoFit/>
-          </a:bodyPr>
-          <a:lstStyle/>
-          <a:p>
-            <a:pPr indent="0" lvl="0" marL="0" rtl="0" algn="ctr">
-              <a:spcBef>
-                <a:spcPts val="0"/>
-              </a:spcBef>
-              <a:spcAft>
-                <a:spcPts val="0"/>
-              </a:spcAft>
-              <a:buNone/>
-            </a:pPr>
-            <a:r>
-              <a:rPr lang="en" sz="2600">
-                <a:latin typeface="Montserrat SemiBold"/>
-                <a:ea typeface="Montserrat SemiBold"/>
-                <a:cs typeface="Montserrat SemiBold"/>
-                <a:sym typeface="Montserrat SemiBold"/>
-              </a:rPr>
-              <a:t>W I N N E R</a:t>
-            </a:r>
-            <a:endParaRPr sz="2600">
-              <a:latin typeface="Montserrat SemiBold"/>
-              <a:ea typeface="Montserrat SemiBold"/>
-              <a:cs typeface="Montserrat SemiBold"/>
-              <a:sym typeface="Montserrat SemiBold"/>
-            </a:endParaRPr>
-          </a:p>
         </p:txBody>
       </p:sp>
       <p:pic>
@@ -7008,7 +6802,7 @@
                   <a:srgbClr val="CCCCCC"/>
                 </a:solidFill>
               </a:rPr>
-              <a:t>Global Strategic Minerals Corporation</a:t>
+              <a:t>Primary Commodity Fund</a:t>
             </a:r>
             <a:endParaRPr>
               <a:solidFill>
@@ -7185,7 +6979,7 @@
                   <a:srgbClr val="CCCCCC"/>
                 </a:solidFill>
               </a:rPr>
-              <a:t>Global Strategic Minerals Corporation</a:t>
+              <a:t>Primary Commodity Fund</a:t>
             </a:r>
             <a:endParaRPr>
               <a:solidFill>

</xml_diff>